<commit_message>
Put the claim on the opening frame, correct sync drift, retitle two scenes
The opening held a bare eyebrow on a dark frame for roughly six seconds while
the narration was already making its claim. The headline now appears with the
line that speaks it, and the three stats move to a row so there is room for it.

Voice ran ahead of picture from scene 4 on, so scene 3 gives up 1.5s and every
boundary after it moves earlier by the same amount; the sign-off absorbs the
time as additional logo hold.

Retitled in both film and deck:
- "We build these strategic AI assets for portfolio companies"
- "Strategic AI platform: what are we building?"

Co-Authored-By: Claude Opus 5 <noreply@anthropic.com>
Claude-Session: https://claude.ai/code/session_011fEh2PS5BRyMrUQwTCUMHD
</commit_message>
<xml_diff>
--- a/deck/InfinitePossibilities-PortCo-AI.pptx
+++ b/deck/InfinitePossibilities-PortCo-AI.pptx
@@ -9834,7 +9834,7 @@
                 <a:ea typeface="Century Gothic" pitchFamily="34" charset="-122"/>
                 <a:cs typeface="Century Gothic" pitchFamily="34" charset="-120"/>
               </a:rPr>
-              <a:t>We build these strategic assets for portfolio companies</a:t>
+              <a:t>We build these strategic AI assets for portfolio companies</a:t>
             </a:r>
             <a:endParaRPr lang="en-US" sz="2700" dirty="0"/>
           </a:p>
@@ -10573,7 +10573,7 @@
                 <a:ea typeface="Century Gothic" pitchFamily="34" charset="-122"/>
                 <a:cs typeface="Century Gothic" pitchFamily="34" charset="-120"/>
               </a:rPr>
-              <a:t>The architecture of a strategic AI asset</a:t>
+              <a:t>Strategic AI platform: what are we building?</a:t>
             </a:r>
             <a:endParaRPr lang="en-US" sz="2700" dirty="0"/>
           </a:p>

</xml_diff>